<commit_message>
Add MODWT/Fourier/EMD helpers, extension scores, updated slides, and the Shillong notebook extract.
</commit_message>
<xml_diff>
--- a/ATSA_Presentation_updated.pptx
+++ b/ATSA_Presentation_updated.pptx
@@ -27,6 +27,10 @@
     <p:sldId id="280" r:id="rId28"/>
     <p:sldId id="273" r:id="rId20"/>
     <p:sldId id="274" r:id="rId21"/>
+    <p:sldId id="281" r:id="rId19"/>
+    <p:sldId id="282" r:id="rId15"/>
+    <p:sldId id="283" r:id="rId29"/>
+    <p:sldId id="284" r:id="rId30"/>
     <p:sldId id="275" r:id="rId22"/>
   </p:sldIdLst>
   <p:sldSz cx="12192000" cy="6858000"/>
@@ -15164,7 +15168,7 @@
                 </a:solidFill>
                 <a:latin typeface="Calibri"/>
               </a:rPr>
-              <a:t>3. Haar only, no wavelet-family comparison</a:t>
+              <a:t>3. Haar was the letter's only filter (D4 / LA8 now scored)</a:t>
             </a:r>
           </a:p>
           <a:p>
@@ -16072,6 +16076,2294 @@
 </file>
 
 <file path=ppt/slides/slide20.xml><?xml version="1.0" encoding="utf-8"?>
+<p:sld xmlns:a="http://schemas.openxmlformats.org/drawingml/2006/main" xmlns:p="http://schemas.openxmlformats.org/presentationml/2006/main" xmlns:r="http://schemas.openxmlformats.org/officeDocument/2006/relationships">
+  <p:cSld>
+    <p:spTree>
+      <p:nvGrpSpPr>
+        <p:cNvPr id="1" name=""/>
+        <p:cNvGrpSpPr/>
+        <p:nvPr/>
+      </p:nvGrpSpPr>
+      <p:grpSpPr/>
+      <p:sp>
+        <p:nvSpPr>
+          <p:cNvPr id="2" name="TextBox 1"/>
+          <p:cNvSpPr txBox="1"/>
+          <p:nvPr/>
+        </p:nvSpPr>
+        <p:spPr>
+          <a:xfrm>
+            <a:off x="411480" y="201168"/>
+            <a:ext cx="11338560" cy="457200"/>
+          </a:xfrm>
+          <a:prstGeom prst="rect">
+            <a:avLst/>
+          </a:prstGeom>
+          <a:noFill/>
+        </p:spPr>
+        <p:txBody>
+          <a:bodyPr wrap="square">
+            <a:spAutoFit/>
+          </a:bodyPr>
+          <a:lstStyle/>
+          <a:p>
+            <a:pPr algn="l">
+              <a:spcAft>
+                <a:spcPts val="400"/>
+              </a:spcAft>
+            </a:pPr>
+            <a:r>
+              <a:rPr sz="2600" b="1">
+                <a:solidFill>
+                  <a:srgbClr val="1F3A5F"/>
+                </a:solidFill>
+                <a:latin typeface="Calibri"/>
+              </a:rPr>
+              <a:t>What we added on top of the letter</a:t>
+            </a:r>
+          </a:p>
+        </p:txBody>
+      </p:sp>
+      <p:sp>
+        <p:nvSpPr>
+          <p:cNvPr id="3" name="Rectangle 2"/>
+          <p:cNvSpPr/>
+          <p:nvPr/>
+        </p:nvSpPr>
+        <p:spPr>
+          <a:xfrm>
+            <a:off x="411480" y="658368"/>
+            <a:ext cx="11338560" cy="12700"/>
+          </a:xfrm>
+          <a:prstGeom prst="rect">
+            <a:avLst/>
+          </a:prstGeom>
+          <a:solidFill>
+            <a:srgbClr val="1F3A5F"/>
+          </a:solidFill>
+          <a:ln>
+            <a:noFill/>
+          </a:ln>
+        </p:spPr>
+        <p:style>
+          <a:lnRef idx="1">
+            <a:schemeClr val="accent1"/>
+          </a:lnRef>
+          <a:fillRef idx="3">
+            <a:schemeClr val="accent1"/>
+          </a:fillRef>
+          <a:effectRef idx="2">
+            <a:schemeClr val="accent1"/>
+          </a:effectRef>
+          <a:fontRef idx="minor">
+            <a:schemeClr val="lt1"/>
+          </a:fontRef>
+        </p:style>
+        <p:txBody>
+          <a:bodyPr rtlCol="0" anchor="ctr"/>
+          <a:lstStyle/>
+          <a:p>
+            <a:pPr algn="ctr"/>
+          </a:p>
+        </p:txBody>
+      </p:sp>
+      <p:sp>
+        <p:nvSpPr>
+          <p:cNvPr id="4" name="TextBox 3"/>
+          <p:cNvSpPr txBox="1"/>
+          <p:nvPr/>
+        </p:nvSpPr>
+        <p:spPr>
+          <a:xfrm>
+            <a:off x="365760" y="6537960"/>
+            <a:ext cx="9144000" cy="256032"/>
+          </a:xfrm>
+          <a:prstGeom prst="rect">
+            <a:avLst/>
+          </a:prstGeom>
+          <a:noFill/>
+        </p:spPr>
+        <p:txBody>
+          <a:bodyPr wrap="square">
+            <a:spAutoFit/>
+          </a:bodyPr>
+          <a:lstStyle/>
+          <a:p>
+            <a:pPr algn="l">
+              <a:spcAft>
+                <a:spcPts val="400"/>
+              </a:spcAft>
+            </a:pPr>
+            <a:r>
+              <a:rPr sz="1100" b="0">
+                <a:solidFill>
+                  <a:srgbClr val="5A5A5A"/>
+                </a:solidFill>
+                <a:latin typeface="Calibri"/>
+              </a:rPr>
+              <a:t>WaveCatBoost: Hybrid Air Quality Forecasting</a:t>
+            </a:r>
+          </a:p>
+        </p:txBody>
+      </p:sp>
+      <p:sp>
+        <p:nvSpPr>
+          <p:cNvPr id="5" name="TextBox 4"/>
+          <p:cNvSpPr txBox="1"/>
+          <p:nvPr/>
+        </p:nvSpPr>
+        <p:spPr>
+          <a:xfrm>
+            <a:off x="11155680" y="6537960"/>
+            <a:ext cx="640080" cy="256032"/>
+          </a:xfrm>
+          <a:prstGeom prst="rect">
+            <a:avLst/>
+          </a:prstGeom>
+          <a:noFill/>
+        </p:spPr>
+        <p:txBody>
+          <a:bodyPr wrap="square">
+            <a:spAutoFit/>
+          </a:bodyPr>
+          <a:lstStyle/>
+          <a:p>
+            <a:pPr algn="r">
+              <a:spcAft>
+                <a:spcPts val="400"/>
+              </a:spcAft>
+            </a:pPr>
+            <a:r>
+              <a:rPr sz="1100" b="0">
+                <a:solidFill>
+                  <a:srgbClr val="5A5A5A"/>
+                </a:solidFill>
+                <a:latin typeface="Calibri"/>
+              </a:rPr>
+              <a:t>20</a:t>
+            </a:r>
+          </a:p>
+        </p:txBody>
+      </p:sp>
+      <p:sp>
+        <p:nvSpPr>
+          <p:cNvPr id="6" name="TextBox 5"/>
+          <p:cNvSpPr txBox="1"/>
+          <p:nvPr/>
+        </p:nvSpPr>
+        <p:spPr>
+          <a:xfrm>
+            <a:off x="502920" y="960120"/>
+            <a:ext cx="11155680" cy="5303520"/>
+          </a:xfrm>
+          <a:prstGeom prst="rect">
+            <a:avLst/>
+          </a:prstGeom>
+          <a:noFill/>
+        </p:spPr>
+        <p:txBody>
+          <a:bodyPr wrap="square">
+            <a:spAutoFit/>
+          </a:bodyPr>
+          <a:lstStyle/>
+          <a:p>
+            <a:pPr algn="l">
+              <a:spcAft>
+                <a:spcPts val="400"/>
+              </a:spcAft>
+            </a:pPr>
+            <a:r>
+              <a:rPr sz="1600" b="1">
+                <a:solidFill>
+                  <a:srgbClr val="1F3A5F"/>
+                </a:solidFill>
+                <a:latin typeface="Calibri"/>
+              </a:rPr>
+              <a:t>Paper pipeline (Sections 1–9 of analysis.Rmd)</a:t>
+            </a:r>
+          </a:p>
+          <a:p>
+            <a:pPr algn="l">
+              <a:spcAft>
+                <a:spcPts val="400"/>
+              </a:spcAft>
+            </a:pPr>
+            <a:r>
+              <a:rPr sz="1400" b="0">
+                <a:solidFill>
+                  <a:srgbClr val="222222"/>
+                </a:solidFill>
+                <a:latin typeface="Calibri"/>
+              </a:rPr>
+              <a:t>Missing values → hourly files → min-max on train → Haar MODWT → one model per D_k, S_K → IMODWT → conformal PI.</a:t>
+            </a:r>
+          </a:p>
+          <a:p>
+            <a:pPr algn="l">
+              <a:spcAft>
+                <a:spcPts val="400"/>
+              </a:spcAft>
+            </a:pPr>
+            <a:r>
+              <a:rPr sz="1000" b="0">
+                <a:solidFill>
+                  <a:srgbClr val="222222"/>
+                </a:solidFill>
+                <a:latin typeface="Calibri"/>
+              </a:rPr>
+              <a:t/>
+            </a:r>
+          </a:p>
+          <a:p>
+            <a:pPr algn="l">
+              <a:spcAft>
+                <a:spcPts val="400"/>
+              </a:spcAft>
+            </a:pPr>
+            <a:r>
+              <a:rPr sz="1600" b="1">
+                <a:solidFill>
+                  <a:srgbClr val="1F3A5F"/>
+                </a:solidFill>
+                <a:latin typeface="Calibri"/>
+              </a:rPr>
+              <a:t>Cross-questions, implemented in code and in this deck</a:t>
+            </a:r>
+          </a:p>
+          <a:p>
+            <a:pPr algn="l">
+              <a:spcAft>
+                <a:spcPts val="400"/>
+              </a:spcAft>
+            </a:pPr>
+            <a:r>
+              <a:rPr sz="1400" b="0">
+                <a:solidFill>
+                  <a:srgbClr val="222222"/>
+                </a:solidFill>
+                <a:latin typeface="Calibri"/>
+              </a:rPr>
+              <a:t>1. Fourier vs MODWT — global sinusoids cannot be lagged; Haar D_k,t can. Same WaveLGB head, 1-day MASE.</a:t>
+            </a:r>
+          </a:p>
+          <a:p>
+            <a:pPr algn="l">
+              <a:spcAft>
+                <a:spcPts val="400"/>
+              </a:spcAft>
+            </a:pPr>
+            <a:r>
+              <a:rPr sz="1400" b="0">
+                <a:solidFill>
+                  <a:srgbClr val="222222"/>
+                </a:solidFill>
+                <a:latin typeface="Calibri"/>
+              </a:rPr>
+              <a:t>2. EMD — data-adaptive IMFs as an alternative to any wavelet bank.</a:t>
+            </a:r>
+          </a:p>
+          <a:p>
+            <a:pPr algn="l">
+              <a:spcAft>
+                <a:spcPts val="400"/>
+              </a:spcAft>
+            </a:pPr>
+            <a:r>
+              <a:rPr sz="1400" b="0">
+                <a:solidFill>
+                  <a:srgbClr val="222222"/>
+                </a:solidFill>
+                <a:latin typeface="Calibri"/>
+              </a:rPr>
+              <a:t>3. Haar / D4 / LA8 — filter menu sits in the MODWT section; MASE comparison at the end.</a:t>
+            </a:r>
+          </a:p>
+          <a:p>
+            <a:pPr algn="l">
+              <a:spcAft>
+                <a:spcPts val="400"/>
+              </a:spcAft>
+            </a:pPr>
+            <a:r>
+              <a:rPr sz="1000" b="0">
+                <a:solidFill>
+                  <a:srgbClr val="222222"/>
+                </a:solidFill>
+                <a:latin typeface="Calibri"/>
+              </a:rPr>
+              <a:t/>
+            </a:r>
+          </a:p>
+          <a:p>
+            <a:pPr algn="l">
+              <a:spcAft>
+                <a:spcPts val="400"/>
+              </a:spcAft>
+            </a:pPr>
+            <a:r>
+              <a:rPr sz="1400" b="0">
+                <a:solidFill>
+                  <a:srgbClr val="5A5A5A"/>
+                </a:solidFill>
+                <a:latin typeface="Calibri"/>
+              </a:rPr>
+              <a:t>Interactive report: analysis.Rmd (RStudio → Run Document). Scores: run_extensions.R</a:t>
+            </a:r>
+          </a:p>
+        </p:txBody>
+      </p:sp>
+    </p:spTree>
+  </p:cSld>
+  <p:clrMapOvr>
+    <a:masterClrMapping/>
+  </p:clrMapOvr>
+</p:sld>
+</file>
+
+<file path=ppt/slides/slide21.xml><?xml version="1.0" encoding="utf-8"?>
+<p:sld xmlns:a="http://schemas.openxmlformats.org/drawingml/2006/main" xmlns:p="http://schemas.openxmlformats.org/presentationml/2006/main" xmlns:r="http://schemas.openxmlformats.org/officeDocument/2006/relationships">
+  <p:cSld>
+    <p:spTree>
+      <p:nvGrpSpPr>
+        <p:cNvPr id="1" name=""/>
+        <p:cNvGrpSpPr/>
+        <p:nvPr/>
+      </p:nvGrpSpPr>
+      <p:grpSpPr/>
+      <p:sp>
+        <p:nvSpPr>
+          <p:cNvPr id="2" name="TextBox 1"/>
+          <p:cNvSpPr txBox="1"/>
+          <p:nvPr/>
+        </p:nvSpPr>
+        <p:spPr>
+          <a:xfrm>
+            <a:off x="411480" y="201168"/>
+            <a:ext cx="11338560" cy="457200"/>
+          </a:xfrm>
+          <a:prstGeom prst="rect">
+            <a:avLst/>
+          </a:prstGeom>
+          <a:noFill/>
+        </p:spPr>
+        <p:txBody>
+          <a:bodyPr wrap="square">
+            <a:spAutoFit/>
+          </a:bodyPr>
+          <a:lstStyle/>
+          <a:p>
+            <a:pPr algn="l">
+              <a:spcAft>
+                <a:spcPts val="400"/>
+              </a:spcAft>
+            </a:pPr>
+            <a:r>
+              <a:rPr sz="2600" b="1">
+                <a:solidFill>
+                  <a:srgbClr val="1F3A5F"/>
+                </a:solidFill>
+                <a:latin typeface="Calibri"/>
+              </a:rPr>
+              <a:t>Why MODWT, not Fourier?</a:t>
+            </a:r>
+          </a:p>
+        </p:txBody>
+      </p:sp>
+      <p:sp>
+        <p:nvSpPr>
+          <p:cNvPr id="3" name="Rectangle 2"/>
+          <p:cNvSpPr/>
+          <p:nvPr/>
+        </p:nvSpPr>
+        <p:spPr>
+          <a:xfrm>
+            <a:off x="411480" y="658368"/>
+            <a:ext cx="11338560" cy="12700"/>
+          </a:xfrm>
+          <a:prstGeom prst="rect">
+            <a:avLst/>
+          </a:prstGeom>
+          <a:solidFill>
+            <a:srgbClr val="1F3A5F"/>
+          </a:solidFill>
+          <a:ln>
+            <a:noFill/>
+          </a:ln>
+        </p:spPr>
+        <p:style>
+          <a:lnRef idx="1">
+            <a:schemeClr val="accent1"/>
+          </a:lnRef>
+          <a:fillRef idx="3">
+            <a:schemeClr val="accent1"/>
+          </a:fillRef>
+          <a:effectRef idx="2">
+            <a:schemeClr val="accent1"/>
+          </a:effectRef>
+          <a:fontRef idx="minor">
+            <a:schemeClr val="lt1"/>
+          </a:fontRef>
+        </p:style>
+        <p:txBody>
+          <a:bodyPr rtlCol="0" anchor="ctr"/>
+          <a:lstStyle/>
+          <a:p>
+            <a:pPr algn="ctr"/>
+          </a:p>
+        </p:txBody>
+      </p:sp>
+      <p:sp>
+        <p:nvSpPr>
+          <p:cNvPr id="4" name="TextBox 3"/>
+          <p:cNvSpPr txBox="1"/>
+          <p:nvPr/>
+        </p:nvSpPr>
+        <p:spPr>
+          <a:xfrm>
+            <a:off x="365760" y="6537960"/>
+            <a:ext cx="9144000" cy="256032"/>
+          </a:xfrm>
+          <a:prstGeom prst="rect">
+            <a:avLst/>
+          </a:prstGeom>
+          <a:noFill/>
+        </p:spPr>
+        <p:txBody>
+          <a:bodyPr wrap="square">
+            <a:spAutoFit/>
+          </a:bodyPr>
+          <a:lstStyle/>
+          <a:p>
+            <a:pPr algn="l">
+              <a:spcAft>
+                <a:spcPts val="400"/>
+              </a:spcAft>
+            </a:pPr>
+            <a:r>
+              <a:rPr sz="1100" b="0">
+                <a:solidFill>
+                  <a:srgbClr val="5A5A5A"/>
+                </a:solidFill>
+                <a:latin typeface="Calibri"/>
+              </a:rPr>
+              <a:t>WaveCatBoost: Hybrid Air Quality Forecasting</a:t>
+            </a:r>
+          </a:p>
+        </p:txBody>
+      </p:sp>
+      <p:sp>
+        <p:nvSpPr>
+          <p:cNvPr id="5" name="TextBox 4"/>
+          <p:cNvSpPr txBox="1"/>
+          <p:nvPr/>
+        </p:nvSpPr>
+        <p:spPr>
+          <a:xfrm>
+            <a:off x="11155680" y="6537960"/>
+            <a:ext cx="640080" cy="256032"/>
+          </a:xfrm>
+          <a:prstGeom prst="rect">
+            <a:avLst/>
+          </a:prstGeom>
+          <a:noFill/>
+        </p:spPr>
+        <p:txBody>
+          <a:bodyPr wrap="square">
+            <a:spAutoFit/>
+          </a:bodyPr>
+          <a:lstStyle/>
+          <a:p>
+            <a:pPr algn="r">
+              <a:spcAft>
+                <a:spcPts val="400"/>
+              </a:spcAft>
+            </a:pPr>
+            <a:r>
+              <a:rPr sz="1100" b="0">
+                <a:solidFill>
+                  <a:srgbClr val="5A5A5A"/>
+                </a:solidFill>
+                <a:latin typeface="Calibri"/>
+              </a:rPr>
+              <a:t>21</a:t>
+            </a:r>
+          </a:p>
+        </p:txBody>
+      </p:sp>
+      <p:sp>
+        <p:nvSpPr>
+          <p:cNvPr id="6" name="TextBox 5"/>
+          <p:cNvSpPr txBox="1"/>
+          <p:nvPr/>
+        </p:nvSpPr>
+        <p:spPr>
+          <a:xfrm>
+            <a:off x="411480" y="804672"/>
+            <a:ext cx="11338560" cy="365760"/>
+          </a:xfrm>
+          <a:prstGeom prst="rect">
+            <a:avLst/>
+          </a:prstGeom>
+          <a:noFill/>
+        </p:spPr>
+        <p:txBody>
+          <a:bodyPr wrap="square">
+            <a:spAutoFit/>
+          </a:bodyPr>
+          <a:lstStyle/>
+          <a:p>
+            <a:pPr algn="l">
+              <a:spcAft>
+                <a:spcPts val="400"/>
+              </a:spcAft>
+            </a:pPr>
+            <a:r>
+              <a:rPr sz="1500" b="0">
+                <a:solidFill>
+                  <a:srgbClr val="5A5A5A"/>
+                </a:solidFill>
+                <a:latin typeface="Calibri"/>
+              </a:rPr>
+              <a:t>A spike at hour 1000 enters every Fourier bin. Haar D1 keeps the hour it happened.</a:t>
+            </a:r>
+          </a:p>
+        </p:txBody>
+      </p:sp>
+      <p:sp>
+        <p:nvSpPr>
+          <p:cNvPr id="7" name="Rectangle 6"/>
+          <p:cNvSpPr/>
+          <p:nvPr/>
+        </p:nvSpPr>
+        <p:spPr>
+          <a:xfrm>
+            <a:off x="411480" y="1280160"/>
+            <a:ext cx="5532120" cy="4937760"/>
+          </a:xfrm>
+          <a:prstGeom prst="rect">
+            <a:avLst/>
+          </a:prstGeom>
+          <a:solidFill>
+            <a:srgbClr val="F7F9FB"/>
+          </a:solidFill>
+          <a:ln w="9525">
+            <a:solidFill>
+              <a:srgbClr val="C8D0D8"/>
+            </a:solidFill>
+          </a:ln>
+        </p:spPr>
+        <p:style>
+          <a:lnRef idx="1">
+            <a:schemeClr val="accent1"/>
+          </a:lnRef>
+          <a:fillRef idx="3">
+            <a:schemeClr val="accent1"/>
+          </a:fillRef>
+          <a:effectRef idx="2">
+            <a:schemeClr val="accent1"/>
+          </a:effectRef>
+          <a:fontRef idx="minor">
+            <a:schemeClr val="lt1"/>
+          </a:fontRef>
+        </p:style>
+        <p:txBody>
+          <a:bodyPr rtlCol="0" anchor="ctr"/>
+          <a:lstStyle/>
+          <a:p>
+            <a:pPr algn="ctr"/>
+          </a:p>
+        </p:txBody>
+      </p:sp>
+      <p:sp>
+        <p:nvSpPr>
+          <p:cNvPr id="8" name="Rectangle 7"/>
+          <p:cNvSpPr/>
+          <p:nvPr/>
+        </p:nvSpPr>
+        <p:spPr>
+          <a:xfrm>
+            <a:off x="6217920" y="1280160"/>
+            <a:ext cx="5532120" cy="4937760"/>
+          </a:xfrm>
+          <a:prstGeom prst="rect">
+            <a:avLst/>
+          </a:prstGeom>
+          <a:solidFill>
+            <a:srgbClr val="F7F9FB"/>
+          </a:solidFill>
+          <a:ln w="9525">
+            <a:solidFill>
+              <a:srgbClr val="C8D0D8"/>
+            </a:solidFill>
+          </a:ln>
+        </p:spPr>
+        <p:style>
+          <a:lnRef idx="1">
+            <a:schemeClr val="accent1"/>
+          </a:lnRef>
+          <a:fillRef idx="3">
+            <a:schemeClr val="accent1"/>
+          </a:fillRef>
+          <a:effectRef idx="2">
+            <a:schemeClr val="accent1"/>
+          </a:effectRef>
+          <a:fontRef idx="minor">
+            <a:schemeClr val="lt1"/>
+          </a:fontRef>
+        </p:style>
+        <p:txBody>
+          <a:bodyPr rtlCol="0" anchor="ctr"/>
+          <a:lstStyle/>
+          <a:p>
+            <a:pPr algn="ctr"/>
+          </a:p>
+        </p:txBody>
+      </p:sp>
+      <p:sp>
+        <p:nvSpPr>
+          <p:cNvPr id="9" name="TextBox 8"/>
+          <p:cNvSpPr txBox="1"/>
+          <p:nvPr/>
+        </p:nvSpPr>
+        <p:spPr>
+          <a:xfrm>
+            <a:off x="594360" y="1417320"/>
+            <a:ext cx="5212080" cy="365760"/>
+          </a:xfrm>
+          <a:prstGeom prst="rect">
+            <a:avLst/>
+          </a:prstGeom>
+          <a:noFill/>
+        </p:spPr>
+        <p:txBody>
+          <a:bodyPr wrap="square">
+            <a:spAutoFit/>
+          </a:bodyPr>
+          <a:lstStyle/>
+          <a:p>
+            <a:pPr algn="l">
+              <a:spcAft>
+                <a:spcPts val="400"/>
+              </a:spcAft>
+            </a:pPr>
+            <a:r>
+              <a:rPr sz="1800" b="1">
+                <a:solidFill>
+                  <a:srgbClr val="A64B2A"/>
+                </a:solidFill>
+                <a:latin typeface="Calibri"/>
+              </a:rPr>
+              <a:t>Fourier (FFT)</a:t>
+            </a:r>
+          </a:p>
+        </p:txBody>
+      </p:sp>
+      <p:sp>
+        <p:nvSpPr>
+          <p:cNvPr id="10" name="TextBox 9"/>
+          <p:cNvSpPr txBox="1"/>
+          <p:nvPr/>
+        </p:nvSpPr>
+        <p:spPr>
+          <a:xfrm>
+            <a:off x="6400800" y="1417320"/>
+            <a:ext cx="5212080" cy="365760"/>
+          </a:xfrm>
+          <a:prstGeom prst="rect">
+            <a:avLst/>
+          </a:prstGeom>
+          <a:noFill/>
+        </p:spPr>
+        <p:txBody>
+          <a:bodyPr wrap="square">
+            <a:spAutoFit/>
+          </a:bodyPr>
+          <a:lstStyle/>
+          <a:p>
+            <a:pPr algn="l">
+              <a:spcAft>
+                <a:spcPts val="400"/>
+              </a:spcAft>
+            </a:pPr>
+            <a:r>
+              <a:rPr sz="1800" b="1">
+                <a:solidFill>
+                  <a:srgbClr val="1F3A5F"/>
+                </a:solidFill>
+                <a:latin typeface="Calibri"/>
+              </a:rPr>
+              <a:t>Haar MODWT  (letter)</a:t>
+            </a:r>
+          </a:p>
+        </p:txBody>
+      </p:sp>
+      <p:sp>
+        <p:nvSpPr>
+          <p:cNvPr id="11" name="TextBox 10"/>
+          <p:cNvSpPr txBox="1"/>
+          <p:nvPr/>
+        </p:nvSpPr>
+        <p:spPr>
+          <a:xfrm>
+            <a:off x="594360" y="1920240"/>
+            <a:ext cx="5212080" cy="3931920"/>
+          </a:xfrm>
+          <a:prstGeom prst="rect">
+            <a:avLst/>
+          </a:prstGeom>
+          <a:noFill/>
+        </p:spPr>
+        <p:txBody>
+          <a:bodyPr wrap="square">
+            <a:spAutoFit/>
+          </a:bodyPr>
+          <a:lstStyle/>
+          <a:p>
+            <a:pPr algn="l">
+              <a:spcAft>
+                <a:spcPts val="400"/>
+              </a:spcAft>
+            </a:pPr>
+            <a:r>
+              <a:rPr sz="1500" b="0">
+                <a:solidFill>
+                  <a:srgbClr val="222222"/>
+                </a:solidFill>
+                <a:latin typeface="Calibri"/>
+              </a:rPr>
+              <a:t>No time index — one coefficient per frequency</a:t>
+            </a:r>
+          </a:p>
+          <a:p>
+            <a:pPr algn="l">
+              <a:spcAft>
+                <a:spcPts val="400"/>
+              </a:spcAft>
+            </a:pPr>
+            <a:r>
+              <a:rPr sz="1500" b="0">
+                <a:solidFill>
+                  <a:srgbClr val="222222"/>
+                </a:solidFill>
+                <a:latin typeface="Calibri"/>
+              </a:rPr>
+              <a:t>A pollution spike is smeared across the whole window</a:t>
+            </a:r>
+          </a:p>
+          <a:p>
+            <a:pPr algn="l">
+              <a:spcAft>
+                <a:spcPts val="400"/>
+              </a:spcAft>
+            </a:pPr>
+            <a:r>
+              <a:rPr sz="1500" b="0">
+                <a:solidFill>
+                  <a:srgbClr val="222222"/>
+                </a:solidFill>
+                <a:latin typeface="Calibri"/>
+              </a:rPr>
+              <a:t>Assumes the same frequencies hold in winter and monsoon</a:t>
+            </a:r>
+          </a:p>
+          <a:p>
+            <a:pPr algn="l">
+              <a:spcAft>
+                <a:spcPts val="400"/>
+              </a:spcAft>
+            </a:pPr>
+            <a:r>
+              <a:rPr sz="1500" b="0">
+                <a:solidFill>
+                  <a:srgbClr val="222222"/>
+                </a:solidFill>
+                <a:latin typeface="Calibri"/>
+              </a:rPr>
+              <a:t>Cannot build lag features F(ω, t−1) for a tree</a:t>
+            </a:r>
+          </a:p>
+          <a:p>
+            <a:pPr algn="l">
+              <a:spcAft>
+                <a:spcPts val="400"/>
+              </a:spcAft>
+            </a:pPr>
+            <a:r>
+              <a:rPr sz="1500" b="0">
+                <a:solidFill>
+                  <a:srgbClr val="222222"/>
+                </a:solidFill>
+                <a:latin typeface="Calibri"/>
+              </a:rPr>
+              <a:t>Reconstruction: IFFT of kept bins</a:t>
+            </a:r>
+          </a:p>
+        </p:txBody>
+      </p:sp>
+      <p:sp>
+        <p:nvSpPr>
+          <p:cNvPr id="12" name="TextBox 11"/>
+          <p:cNvSpPr txBox="1"/>
+          <p:nvPr/>
+        </p:nvSpPr>
+        <p:spPr>
+          <a:xfrm>
+            <a:off x="6400800" y="1920240"/>
+            <a:ext cx="5212080" cy="3931920"/>
+          </a:xfrm>
+          <a:prstGeom prst="rect">
+            <a:avLst/>
+          </a:prstGeom>
+          <a:noFill/>
+        </p:spPr>
+        <p:txBody>
+          <a:bodyPr wrap="square">
+            <a:spAutoFit/>
+          </a:bodyPr>
+          <a:lstStyle/>
+          <a:p>
+            <a:pPr algn="l">
+              <a:spcAft>
+                <a:spcPts val="400"/>
+              </a:spcAft>
+            </a:pPr>
+            <a:r>
+              <a:rPr sz="1500" b="0">
+                <a:solidFill>
+                  <a:srgbClr val="222222"/>
+                </a:solidFill>
+                <a:latin typeface="Calibri"/>
+              </a:rPr>
+              <a:t>D_k,t is indexed by time t</a:t>
+            </a:r>
+          </a:p>
+          <a:p>
+            <a:pPr algn="l">
+              <a:spcAft>
+                <a:spcPts val="400"/>
+              </a:spcAft>
+            </a:pPr>
+            <a:r>
+              <a:rPr sz="1500" b="0">
+                <a:solidFill>
+                  <a:srgbClr val="222222"/>
+                </a:solidFill>
+                <a:latin typeface="Calibri"/>
+              </a:rPr>
+              <a:t>The same spike sits in D1 at that hour</a:t>
+            </a:r>
+          </a:p>
+          <a:p>
+            <a:pPr algn="l">
+              <a:spcAft>
+                <a:spcPts val="400"/>
+              </a:spcAft>
+            </a:pPr>
+            <a:r>
+              <a:rPr sz="1500" b="0">
+                <a:solidFill>
+                  <a:srgbClr val="222222"/>
+                </a:solidFill>
+                <a:latin typeface="Calibri"/>
+              </a:rPr>
+              <a:t>Local in time, so a level shift does not leak into every coefficient</a:t>
+            </a:r>
+          </a:p>
+          <a:p>
+            <a:pPr algn="l">
+              <a:spcAft>
+                <a:spcPts val="400"/>
+              </a:spcAft>
+            </a:pPr>
+            <a:r>
+              <a:rPr sz="1500" b="0">
+                <a:solidFill>
+                  <a:srgbClr val="222222"/>
+                </a:solidFill>
+                <a:latin typeface="Calibri"/>
+              </a:rPr>
+              <a:t>Lag D_k,t−1 lines up with Y_t  →  one CatBoost per component</a:t>
+            </a:r>
+          </a:p>
+          <a:p>
+            <a:pPr algn="l">
+              <a:spcAft>
+                <a:spcPts val="400"/>
+              </a:spcAft>
+            </a:pPr>
+            <a:r>
+              <a:rPr sz="1500" b="0">
+                <a:solidFill>
+                  <a:srgbClr val="222222"/>
+                </a:solidFill>
+                <a:latin typeface="Calibri"/>
+              </a:rPr>
+              <a:t>Y_t = Σ D_k,t + S_K,t   (additive MRA / IMODWT)</a:t>
+            </a:r>
+          </a:p>
+        </p:txBody>
+      </p:sp>
+    </p:spTree>
+  </p:cSld>
+  <p:clrMapOvr>
+    <a:masterClrMapping/>
+  </p:clrMapOvr>
+</p:sld>
+</file>
+
+<file path=ppt/slides/slide22.xml><?xml version="1.0" encoding="utf-8"?>
+<p:sld xmlns:a="http://schemas.openxmlformats.org/drawingml/2006/main" xmlns:p="http://schemas.openxmlformats.org/presentationml/2006/main" xmlns:r="http://schemas.openxmlformats.org/officeDocument/2006/relationships">
+  <p:cSld>
+    <p:spTree>
+      <p:nvGrpSpPr>
+        <p:cNvPr id="1" name=""/>
+        <p:cNvGrpSpPr/>
+        <p:nvPr/>
+      </p:nvGrpSpPr>
+      <p:grpSpPr/>
+      <p:sp>
+        <p:nvSpPr>
+          <p:cNvPr id="2" name="TextBox 1"/>
+          <p:cNvSpPr txBox="1"/>
+          <p:nvPr/>
+        </p:nvSpPr>
+        <p:spPr>
+          <a:xfrm>
+            <a:off x="411480" y="201168"/>
+            <a:ext cx="11338560" cy="457200"/>
+          </a:xfrm>
+          <a:prstGeom prst="rect">
+            <a:avLst/>
+          </a:prstGeom>
+          <a:noFill/>
+        </p:spPr>
+        <p:txBody>
+          <a:bodyPr wrap="square">
+            <a:spAutoFit/>
+          </a:bodyPr>
+          <a:lstStyle/>
+          <a:p>
+            <a:pPr algn="l">
+              <a:spcAft>
+                <a:spcPts val="400"/>
+              </a:spcAft>
+            </a:pPr>
+            <a:r>
+              <a:rPr sz="2600" b="1">
+                <a:solidFill>
+                  <a:srgbClr val="1F3A5F"/>
+                </a:solidFill>
+                <a:latin typeface="Calibri"/>
+              </a:rPr>
+              <a:t>Other wavelet filters: Haar, D4, LA8</a:t>
+            </a:r>
+          </a:p>
+        </p:txBody>
+      </p:sp>
+      <p:sp>
+        <p:nvSpPr>
+          <p:cNvPr id="3" name="Rectangle 2"/>
+          <p:cNvSpPr/>
+          <p:nvPr/>
+        </p:nvSpPr>
+        <p:spPr>
+          <a:xfrm>
+            <a:off x="411480" y="658368"/>
+            <a:ext cx="11338560" cy="12700"/>
+          </a:xfrm>
+          <a:prstGeom prst="rect">
+            <a:avLst/>
+          </a:prstGeom>
+          <a:solidFill>
+            <a:srgbClr val="1F3A5F"/>
+          </a:solidFill>
+          <a:ln>
+            <a:noFill/>
+          </a:ln>
+        </p:spPr>
+        <p:style>
+          <a:lnRef idx="1">
+            <a:schemeClr val="accent1"/>
+          </a:lnRef>
+          <a:fillRef idx="3">
+            <a:schemeClr val="accent1"/>
+          </a:fillRef>
+          <a:effectRef idx="2">
+            <a:schemeClr val="accent1"/>
+          </a:effectRef>
+          <a:fontRef idx="minor">
+            <a:schemeClr val="lt1"/>
+          </a:fontRef>
+        </p:style>
+        <p:txBody>
+          <a:bodyPr rtlCol="0" anchor="ctr"/>
+          <a:lstStyle/>
+          <a:p>
+            <a:pPr algn="ctr"/>
+          </a:p>
+        </p:txBody>
+      </p:sp>
+      <p:sp>
+        <p:nvSpPr>
+          <p:cNvPr id="4" name="TextBox 3"/>
+          <p:cNvSpPr txBox="1"/>
+          <p:nvPr/>
+        </p:nvSpPr>
+        <p:spPr>
+          <a:xfrm>
+            <a:off x="365760" y="6537960"/>
+            <a:ext cx="9144000" cy="256032"/>
+          </a:xfrm>
+          <a:prstGeom prst="rect">
+            <a:avLst/>
+          </a:prstGeom>
+          <a:noFill/>
+        </p:spPr>
+        <p:txBody>
+          <a:bodyPr wrap="square">
+            <a:spAutoFit/>
+          </a:bodyPr>
+          <a:lstStyle/>
+          <a:p>
+            <a:pPr algn="l">
+              <a:spcAft>
+                <a:spcPts val="400"/>
+              </a:spcAft>
+            </a:pPr>
+            <a:r>
+              <a:rPr sz="1100" b="0">
+                <a:solidFill>
+                  <a:srgbClr val="5A5A5A"/>
+                </a:solidFill>
+                <a:latin typeface="Calibri"/>
+              </a:rPr>
+              <a:t>WaveCatBoost: Hybrid Air Quality Forecasting</a:t>
+            </a:r>
+          </a:p>
+        </p:txBody>
+      </p:sp>
+      <p:sp>
+        <p:nvSpPr>
+          <p:cNvPr id="5" name="TextBox 4"/>
+          <p:cNvSpPr txBox="1"/>
+          <p:nvPr/>
+        </p:nvSpPr>
+        <p:spPr>
+          <a:xfrm>
+            <a:off x="11155680" y="6537960"/>
+            <a:ext cx="640080" cy="256032"/>
+          </a:xfrm>
+          <a:prstGeom prst="rect">
+            <a:avLst/>
+          </a:prstGeom>
+          <a:noFill/>
+        </p:spPr>
+        <p:txBody>
+          <a:bodyPr wrap="square">
+            <a:spAutoFit/>
+          </a:bodyPr>
+          <a:lstStyle/>
+          <a:p>
+            <a:pPr algn="r">
+              <a:spcAft>
+                <a:spcPts val="400"/>
+              </a:spcAft>
+            </a:pPr>
+            <a:r>
+              <a:rPr sz="1100" b="0">
+                <a:solidFill>
+                  <a:srgbClr val="5A5A5A"/>
+                </a:solidFill>
+                <a:latin typeface="Calibri"/>
+              </a:rPr>
+              <a:t>22</a:t>
+            </a:r>
+          </a:p>
+        </p:txBody>
+      </p:sp>
+      <p:sp>
+        <p:nvSpPr>
+          <p:cNvPr id="6" name="TextBox 5"/>
+          <p:cNvSpPr txBox="1"/>
+          <p:nvPr/>
+        </p:nvSpPr>
+        <p:spPr>
+          <a:xfrm>
+            <a:off x="411480" y="804672"/>
+            <a:ext cx="11338560" cy="411480"/>
+          </a:xfrm>
+          <a:prstGeom prst="rect">
+            <a:avLst/>
+          </a:prstGeom>
+          <a:noFill/>
+        </p:spPr>
+        <p:txBody>
+          <a:bodyPr wrap="square">
+            <a:spAutoFit/>
+          </a:bodyPr>
+          <a:lstStyle/>
+          <a:p>
+            <a:pPr algn="l">
+              <a:spcAft>
+                <a:spcPts val="400"/>
+              </a:spcAft>
+            </a:pPr>
+            <a:r>
+              <a:rPr sz="1500" b="0">
+                <a:solidFill>
+                  <a:srgbClr val="5A5A5A"/>
+                </a:solidFill>
+                <a:latin typeface="Calibri"/>
+              </a:rPr>
+              <a:t>The letter uses Haar (two taps). D4 (4 taps) and LA8 (8 taps) are smoother octave filters. Reconstruction is still Y_t = Σ D_k,t + S_K,t.</a:t>
+            </a:r>
+          </a:p>
+        </p:txBody>
+      </p:sp>
+      <p:sp>
+        <p:nvSpPr>
+          <p:cNvPr id="7" name="Rectangle 6"/>
+          <p:cNvSpPr/>
+          <p:nvPr/>
+        </p:nvSpPr>
+        <p:spPr>
+          <a:xfrm>
+            <a:off x="411480" y="1325880"/>
+            <a:ext cx="3657600" cy="2148840"/>
+          </a:xfrm>
+          <a:prstGeom prst="rect">
+            <a:avLst/>
+          </a:prstGeom>
+          <a:solidFill>
+            <a:srgbClr val="EEF2F7"/>
+          </a:solidFill>
+          <a:ln w="9525">
+            <a:solidFill>
+              <a:srgbClr val="C8D0D8"/>
+            </a:solidFill>
+          </a:ln>
+        </p:spPr>
+        <p:style>
+          <a:lnRef idx="1">
+            <a:schemeClr val="accent1"/>
+          </a:lnRef>
+          <a:fillRef idx="3">
+            <a:schemeClr val="accent1"/>
+          </a:fillRef>
+          <a:effectRef idx="2">
+            <a:schemeClr val="accent1"/>
+          </a:effectRef>
+          <a:fontRef idx="minor">
+            <a:schemeClr val="lt1"/>
+          </a:fontRef>
+        </p:style>
+        <p:txBody>
+          <a:bodyPr rtlCol="0" anchor="ctr"/>
+          <a:lstStyle/>
+          <a:p>
+            <a:pPr algn="ctr"/>
+          </a:p>
+        </p:txBody>
+      </p:sp>
+      <p:sp>
+        <p:nvSpPr>
+          <p:cNvPr id="8" name="Rectangle 7"/>
+          <p:cNvSpPr/>
+          <p:nvPr/>
+        </p:nvSpPr>
+        <p:spPr>
+          <a:xfrm>
+            <a:off x="4251960" y="1325880"/>
+            <a:ext cx="3657600" cy="2148840"/>
+          </a:xfrm>
+          <a:prstGeom prst="rect">
+            <a:avLst/>
+          </a:prstGeom>
+          <a:solidFill>
+            <a:srgbClr val="F8F0EC"/>
+          </a:solidFill>
+          <a:ln w="9525">
+            <a:solidFill>
+              <a:srgbClr val="C8D0D8"/>
+            </a:solidFill>
+          </a:ln>
+        </p:spPr>
+        <p:style>
+          <a:lnRef idx="1">
+            <a:schemeClr val="accent1"/>
+          </a:lnRef>
+          <a:fillRef idx="3">
+            <a:schemeClr val="accent1"/>
+          </a:fillRef>
+          <a:effectRef idx="2">
+            <a:schemeClr val="accent1"/>
+          </a:effectRef>
+          <a:fontRef idx="minor">
+            <a:schemeClr val="lt1"/>
+          </a:fontRef>
+        </p:style>
+        <p:txBody>
+          <a:bodyPr rtlCol="0" anchor="ctr"/>
+          <a:lstStyle/>
+          <a:p>
+            <a:pPr algn="ctr"/>
+          </a:p>
+        </p:txBody>
+      </p:sp>
+      <p:sp>
+        <p:nvSpPr>
+          <p:cNvPr id="9" name="Rectangle 8"/>
+          <p:cNvSpPr/>
+          <p:nvPr/>
+        </p:nvSpPr>
+        <p:spPr>
+          <a:xfrm>
+            <a:off x="8092440" y="1325880"/>
+            <a:ext cx="3657600" cy="2148840"/>
+          </a:xfrm>
+          <a:prstGeom prst="rect">
+            <a:avLst/>
+          </a:prstGeom>
+          <a:solidFill>
+            <a:srgbClr val="ECF4EF"/>
+          </a:solidFill>
+          <a:ln w="9525">
+            <a:solidFill>
+              <a:srgbClr val="C8D0D8"/>
+            </a:solidFill>
+          </a:ln>
+        </p:spPr>
+        <p:style>
+          <a:lnRef idx="1">
+            <a:schemeClr val="accent1"/>
+          </a:lnRef>
+          <a:fillRef idx="3">
+            <a:schemeClr val="accent1"/>
+          </a:fillRef>
+          <a:effectRef idx="2">
+            <a:schemeClr val="accent1"/>
+          </a:effectRef>
+          <a:fontRef idx="minor">
+            <a:schemeClr val="lt1"/>
+          </a:fontRef>
+        </p:style>
+        <p:txBody>
+          <a:bodyPr rtlCol="0" anchor="ctr"/>
+          <a:lstStyle/>
+          <a:p>
+            <a:pPr algn="ctr"/>
+          </a:p>
+        </p:txBody>
+      </p:sp>
+      <p:sp>
+        <p:nvSpPr>
+          <p:cNvPr id="10" name="TextBox 9"/>
+          <p:cNvSpPr txBox="1"/>
+          <p:nvPr/>
+        </p:nvSpPr>
+        <p:spPr>
+          <a:xfrm>
+            <a:off x="548640" y="1417320"/>
+            <a:ext cx="3383280" cy="1920240"/>
+          </a:xfrm>
+          <a:prstGeom prst="rect">
+            <a:avLst/>
+          </a:prstGeom>
+          <a:noFill/>
+        </p:spPr>
+        <p:txBody>
+          <a:bodyPr wrap="square">
+            <a:spAutoFit/>
+          </a:bodyPr>
+          <a:lstStyle/>
+          <a:p>
+            <a:pPr algn="l">
+              <a:spcAft>
+                <a:spcPts val="400"/>
+              </a:spcAft>
+            </a:pPr>
+            <a:r>
+              <a:rPr sz="1600" b="1">
+                <a:solidFill>
+                  <a:srgbClr val="1F3A5F"/>
+                </a:solidFill>
+                <a:latin typeface="Calibri"/>
+              </a:rPr>
+              <a:t>Haar  (paper)</a:t>
+            </a:r>
+          </a:p>
+          <a:p>
+            <a:pPr algn="l">
+              <a:spcAft>
+                <a:spcPts val="400"/>
+              </a:spcAft>
+            </a:pPr>
+            <a:r>
+              <a:rPr sz="1400" b="0">
+                <a:solidFill>
+                  <a:srgbClr val="222222"/>
+                </a:solidFill>
+                <a:latin typeface="Calibri"/>
+              </a:rPr>
+              <a:t>p = ½(1, −1),  q = ½(1, 1)</a:t>
+            </a:r>
+          </a:p>
+          <a:p>
+            <a:pPr algn="l">
+              <a:spcAft>
+                <a:spcPts val="400"/>
+              </a:spcAft>
+            </a:pPr>
+            <a:r>
+              <a:rPr sz="1400" b="0">
+                <a:solidFill>
+                  <a:srgbClr val="222222"/>
+                </a:solidFill>
+                <a:latin typeface="Calibri"/>
+              </a:rPr>
+              <a:t>Shortest support. D1 is jagged.</a:t>
+            </a:r>
+          </a:p>
+          <a:p>
+            <a:pPr algn="l">
+              <a:spcAft>
+                <a:spcPts val="400"/>
+              </a:spcAft>
+            </a:pPr>
+            <a:r>
+              <a:rPr sz="1400" b="0">
+                <a:solidFill>
+                  <a:srgbClr val="222222"/>
+                </a:solidFill>
+                <a:latin typeface="Calibri"/>
+              </a:rPr>
+              <a:t>Default in WaveCatBoost.</a:t>
+            </a:r>
+          </a:p>
+        </p:txBody>
+      </p:sp>
+      <p:sp>
+        <p:nvSpPr>
+          <p:cNvPr id="11" name="TextBox 10"/>
+          <p:cNvSpPr txBox="1"/>
+          <p:nvPr/>
+        </p:nvSpPr>
+        <p:spPr>
+          <a:xfrm>
+            <a:off x="4389120" y="1417320"/>
+            <a:ext cx="3383280" cy="1920240"/>
+          </a:xfrm>
+          <a:prstGeom prst="rect">
+            <a:avLst/>
+          </a:prstGeom>
+          <a:noFill/>
+        </p:spPr>
+        <p:txBody>
+          <a:bodyPr wrap="square">
+            <a:spAutoFit/>
+          </a:bodyPr>
+          <a:lstStyle/>
+          <a:p>
+            <a:pPr algn="l">
+              <a:spcAft>
+                <a:spcPts val="400"/>
+              </a:spcAft>
+            </a:pPr>
+            <a:r>
+              <a:rPr sz="1600" b="1">
+                <a:solidFill>
+                  <a:srgbClr val="A64B2A"/>
+                </a:solidFill>
+                <a:latin typeface="Calibri"/>
+              </a:rPr>
+              <a:t>Daubechies-4</a:t>
+            </a:r>
+          </a:p>
+          <a:p>
+            <a:pPr algn="l">
+              <a:spcAft>
+                <a:spcPts val="400"/>
+              </a:spcAft>
+            </a:pPr>
+            <a:r>
+              <a:rPr sz="1400" b="0">
+                <a:solidFill>
+                  <a:srgbClr val="222222"/>
+                </a:solidFill>
+                <a:latin typeface="Calibri"/>
+              </a:rPr>
+              <a:t>4 taps, cleaner band split</a:t>
+            </a:r>
+          </a:p>
+          <a:p>
+            <a:pPr algn="l">
+              <a:spcAft>
+                <a:spcPts val="400"/>
+              </a:spcAft>
+            </a:pPr>
+            <a:r>
+              <a:rPr sz="1400" b="0">
+                <a:solidFill>
+                  <a:srgbClr val="222222"/>
+                </a:solidFill>
+                <a:latin typeface="Calibri"/>
+              </a:rPr>
+              <a:t>A spike in D1 lasts a few extra hours.</a:t>
+            </a:r>
+          </a:p>
+          <a:p>
+            <a:pPr algn="l">
+              <a:spcAft>
+                <a:spcPts val="400"/>
+              </a:spcAft>
+            </a:pPr>
+            <a:r>
+              <a:rPr sz="1400" b="0">
+                <a:solidFill>
+                  <a:srgbClr val="222222"/>
+                </a:solidFill>
+                <a:latin typeface="Calibri"/>
+              </a:rPr>
+              <a:t>Extension — same WaveLGB head.</a:t>
+            </a:r>
+          </a:p>
+        </p:txBody>
+      </p:sp>
+      <p:sp>
+        <p:nvSpPr>
+          <p:cNvPr id="12" name="TextBox 11"/>
+          <p:cNvSpPr txBox="1"/>
+          <p:nvPr/>
+        </p:nvSpPr>
+        <p:spPr>
+          <a:xfrm>
+            <a:off x="8229600" y="1417320"/>
+            <a:ext cx="3383280" cy="1920240"/>
+          </a:xfrm>
+          <a:prstGeom prst="rect">
+            <a:avLst/>
+          </a:prstGeom>
+          <a:noFill/>
+        </p:spPr>
+        <p:txBody>
+          <a:bodyPr wrap="square">
+            <a:spAutoFit/>
+          </a:bodyPr>
+          <a:lstStyle/>
+          <a:p>
+            <a:pPr algn="l">
+              <a:spcAft>
+                <a:spcPts val="400"/>
+              </a:spcAft>
+            </a:pPr>
+            <a:r>
+              <a:rPr sz="1600" b="1">
+                <a:solidFill>
+                  <a:srgbClr val="2E6B4F"/>
+                </a:solidFill>
+                <a:latin typeface="Calibri"/>
+              </a:rPr>
+              <a:t>Least-Asymmetric-8</a:t>
+            </a:r>
+          </a:p>
+          <a:p>
+            <a:pPr algn="l">
+              <a:spcAft>
+                <a:spcPts val="400"/>
+              </a:spcAft>
+            </a:pPr>
+            <a:r>
+              <a:rPr sz="1400" b="0">
+                <a:solidFill>
+                  <a:srgbClr val="222222"/>
+                </a:solidFill>
+                <a:latin typeface="Calibri"/>
+              </a:rPr>
+              <a:t>8 taps, near-linear phase</a:t>
+            </a:r>
+          </a:p>
+          <a:p>
+            <a:pPr algn="l">
+              <a:spcAft>
+                <a:spcPts val="400"/>
+              </a:spcAft>
+            </a:pPr>
+            <a:r>
+              <a:rPr sz="1400" b="0">
+                <a:solidFill>
+                  <a:srgbClr val="222222"/>
+                </a:solidFill>
+                <a:latin typeface="Calibri"/>
+              </a:rPr>
+              <a:t>Smoothest D_k of the three.</a:t>
+            </a:r>
+          </a:p>
+          <a:p>
+            <a:pPr algn="l">
+              <a:spcAft>
+                <a:spcPts val="400"/>
+              </a:spcAft>
+            </a:pPr>
+            <a:r>
+              <a:rPr sz="1400" b="0">
+                <a:solidFill>
+                  <a:srgbClr val="222222"/>
+                </a:solidFill>
+                <a:latin typeface="Calibri"/>
+              </a:rPr>
+              <a:t>Extension — same WaveLGB head.</a:t>
+            </a:r>
+          </a:p>
+        </p:txBody>
+      </p:sp>
+      <p:sp>
+        <p:nvSpPr>
+          <p:cNvPr id="13" name="TextBox 12"/>
+          <p:cNvSpPr txBox="1"/>
+          <p:nvPr/>
+        </p:nvSpPr>
+        <p:spPr>
+          <a:xfrm>
+            <a:off x="411480" y="3611880"/>
+            <a:ext cx="11338560" cy="320040"/>
+          </a:xfrm>
+          <a:prstGeom prst="rect">
+            <a:avLst/>
+          </a:prstGeom>
+          <a:noFill/>
+        </p:spPr>
+        <p:txBody>
+          <a:bodyPr wrap="square">
+            <a:spAutoFit/>
+          </a:bodyPr>
+          <a:lstStyle/>
+          <a:p>
+            <a:pPr algn="l">
+              <a:spcAft>
+                <a:spcPts val="400"/>
+              </a:spcAft>
+            </a:pPr>
+            <a:r>
+              <a:rPr sz="1400" b="1">
+                <a:solidFill>
+                  <a:srgbClr val="1F3A5F"/>
+                </a:solidFill>
+                <a:latin typeface="Calibri"/>
+              </a:rPr>
+              <a:t>WaveLGB MASE, 1-day horizon (lower is better). Same K, p, and split.</a:t>
+            </a:r>
+          </a:p>
+        </p:txBody>
+      </p:sp>
+      <p:sp>
+        <p:nvSpPr>
+          <p:cNvPr id="14" name="TextBox 13"/>
+          <p:cNvSpPr txBox="1"/>
+          <p:nvPr/>
+        </p:nvSpPr>
+        <p:spPr>
+          <a:xfrm>
+            <a:off x="411480" y="3977639"/>
+            <a:ext cx="11338560" cy="2194560"/>
+          </a:xfrm>
+          <a:prstGeom prst="rect">
+            <a:avLst/>
+          </a:prstGeom>
+          <a:noFill/>
+        </p:spPr>
+        <p:txBody>
+          <a:bodyPr wrap="square">
+            <a:spAutoFit/>
+          </a:bodyPr>
+          <a:lstStyle/>
+          <a:p>
+            <a:pPr algn="l">
+              <a:spcAft>
+                <a:spcPts val="400"/>
+              </a:spcAft>
+            </a:pPr>
+            <a:r>
+              <a:rPr sz="1500" b="1">
+                <a:solidFill>
+                  <a:srgbClr val="1F3A5F"/>
+                </a:solidFill>
+                <a:latin typeface="Calibri"/>
+              </a:rPr>
+              <a:t>Series                  Haar     D4      LA8     Fourier</a:t>
+            </a:r>
+          </a:p>
+          <a:p>
+            <a:pPr algn="l">
+              <a:spcAft>
+                <a:spcPts val="400"/>
+              </a:spcAft>
+            </a:pPr>
+            <a:r>
+              <a:rPr sz="1500" b="0">
+                <a:solidFill>
+                  <a:srgbClr val="222222"/>
+                </a:solidFill>
+                <a:latin typeface="Calibri"/>
+              </a:rPr>
+              <a:t>CPCB PM2.5             1.031   1.250   1.112   1.272</a:t>
+            </a:r>
+          </a:p>
+          <a:p>
+            <a:pPr algn="l">
+              <a:spcAft>
+                <a:spcPts val="400"/>
+              </a:spcAft>
+            </a:pPr>
+            <a:r>
+              <a:rPr sz="1500" b="0">
+                <a:solidFill>
+                  <a:srgbClr val="222222"/>
+                </a:solidFill>
+                <a:latin typeface="Calibri"/>
+              </a:rPr>
+              <a:t>CPCB NO2               0.518   0.519   0.534   0.692</a:t>
+            </a:r>
+          </a:p>
+          <a:p>
+            <a:pPr algn="l">
+              <a:spcAft>
+                <a:spcPts val="400"/>
+              </a:spcAft>
+            </a:pPr>
+            <a:r>
+              <a:rPr sz="1500" b="0">
+                <a:solidFill>
+                  <a:srgbClr val="222222"/>
+                </a:solidFill>
+                <a:latin typeface="Calibri"/>
+              </a:rPr>
+              <a:t>ID1  PM2.5             0.360   0.414   0.476   0.473</a:t>
+            </a:r>
+          </a:p>
+          <a:p>
+            <a:pPr algn="l">
+              <a:spcAft>
+                <a:spcPts val="400"/>
+              </a:spcAft>
+            </a:pPr>
+            <a:r>
+              <a:rPr sz="1500" b="0">
+                <a:solidFill>
+                  <a:srgbClr val="222222"/>
+                </a:solidFill>
+                <a:latin typeface="Calibri"/>
+              </a:rPr>
+              <a:t>ID1  NO2               1.259   1.309   1.324   1.438</a:t>
+            </a:r>
+          </a:p>
+          <a:p>
+            <a:pPr algn="l">
+              <a:spcAft>
+                <a:spcPts val="400"/>
+              </a:spcAft>
+            </a:pPr>
+            <a:r>
+              <a:rPr sz="1400" b="0">
+                <a:solidFill>
+                  <a:srgbClr val="5A5A5A"/>
+                </a:solidFill>
+                <a:latin typeface="Calibri"/>
+              </a:rPr>
+              <a:t>Haar is lowest (or tied) on these 1-day cases. Extra taps clean the D_k plot, not the MASE.</a:t>
+            </a:r>
+          </a:p>
+        </p:txBody>
+      </p:sp>
+    </p:spTree>
+  </p:cSld>
+  <p:clrMapOvr>
+    <a:masterClrMapping/>
+  </p:clrMapOvr>
+</p:sld>
+</file>
+
+<file path=ppt/slides/slide23.xml><?xml version="1.0" encoding="utf-8"?>
+<p:sld xmlns:a="http://schemas.openxmlformats.org/drawingml/2006/main" xmlns:p="http://schemas.openxmlformats.org/presentationml/2006/main" xmlns:r="http://schemas.openxmlformats.org/officeDocument/2006/relationships">
+  <p:cSld>
+    <p:spTree>
+      <p:nvGrpSpPr>
+        <p:cNvPr id="1" name=""/>
+        <p:cNvGrpSpPr/>
+        <p:nvPr/>
+      </p:nvGrpSpPr>
+      <p:grpSpPr/>
+      <p:sp>
+        <p:nvSpPr>
+          <p:cNvPr id="2" name="TextBox 1"/>
+          <p:cNvSpPr txBox="1"/>
+          <p:nvPr/>
+        </p:nvSpPr>
+        <p:spPr>
+          <a:xfrm>
+            <a:off x="411480" y="201168"/>
+            <a:ext cx="11338560" cy="457200"/>
+          </a:xfrm>
+          <a:prstGeom prst="rect">
+            <a:avLst/>
+          </a:prstGeom>
+          <a:noFill/>
+        </p:spPr>
+        <p:txBody>
+          <a:bodyPr wrap="square">
+            <a:spAutoFit/>
+          </a:bodyPr>
+          <a:lstStyle/>
+          <a:p>
+            <a:pPr algn="l">
+              <a:spcAft>
+                <a:spcPts val="400"/>
+              </a:spcAft>
+            </a:pPr>
+            <a:r>
+              <a:rPr sz="2600" b="1">
+                <a:solidFill>
+                  <a:srgbClr val="1F3A5F"/>
+                </a:solidFill>
+                <a:latin typeface="Calibri"/>
+              </a:rPr>
+              <a:t>Another decomposition: Empirical Mode Decomposition</a:t>
+            </a:r>
+          </a:p>
+        </p:txBody>
+      </p:sp>
+      <p:sp>
+        <p:nvSpPr>
+          <p:cNvPr id="3" name="Rectangle 2"/>
+          <p:cNvSpPr/>
+          <p:nvPr/>
+        </p:nvSpPr>
+        <p:spPr>
+          <a:xfrm>
+            <a:off x="411480" y="658368"/>
+            <a:ext cx="11338560" cy="12700"/>
+          </a:xfrm>
+          <a:prstGeom prst="rect">
+            <a:avLst/>
+          </a:prstGeom>
+          <a:solidFill>
+            <a:srgbClr val="1F3A5F"/>
+          </a:solidFill>
+          <a:ln>
+            <a:noFill/>
+          </a:ln>
+        </p:spPr>
+        <p:style>
+          <a:lnRef idx="1">
+            <a:schemeClr val="accent1"/>
+          </a:lnRef>
+          <a:fillRef idx="3">
+            <a:schemeClr val="accent1"/>
+          </a:fillRef>
+          <a:effectRef idx="2">
+            <a:schemeClr val="accent1"/>
+          </a:effectRef>
+          <a:fontRef idx="minor">
+            <a:schemeClr val="lt1"/>
+          </a:fontRef>
+        </p:style>
+        <p:txBody>
+          <a:bodyPr rtlCol="0" anchor="ctr"/>
+          <a:lstStyle/>
+          <a:p>
+            <a:pPr algn="ctr"/>
+          </a:p>
+        </p:txBody>
+      </p:sp>
+      <p:sp>
+        <p:nvSpPr>
+          <p:cNvPr id="4" name="TextBox 3"/>
+          <p:cNvSpPr txBox="1"/>
+          <p:nvPr/>
+        </p:nvSpPr>
+        <p:spPr>
+          <a:xfrm>
+            <a:off x="365760" y="6537960"/>
+            <a:ext cx="9144000" cy="256032"/>
+          </a:xfrm>
+          <a:prstGeom prst="rect">
+            <a:avLst/>
+          </a:prstGeom>
+          <a:noFill/>
+        </p:spPr>
+        <p:txBody>
+          <a:bodyPr wrap="square">
+            <a:spAutoFit/>
+          </a:bodyPr>
+          <a:lstStyle/>
+          <a:p>
+            <a:pPr algn="l">
+              <a:spcAft>
+                <a:spcPts val="400"/>
+              </a:spcAft>
+            </a:pPr>
+            <a:r>
+              <a:rPr sz="1100" b="0">
+                <a:solidFill>
+                  <a:srgbClr val="5A5A5A"/>
+                </a:solidFill>
+                <a:latin typeface="Calibri"/>
+              </a:rPr>
+              <a:t>WaveCatBoost: Hybrid Air Quality Forecasting</a:t>
+            </a:r>
+          </a:p>
+        </p:txBody>
+      </p:sp>
+      <p:sp>
+        <p:nvSpPr>
+          <p:cNvPr id="5" name="TextBox 4"/>
+          <p:cNvSpPr txBox="1"/>
+          <p:nvPr/>
+        </p:nvSpPr>
+        <p:spPr>
+          <a:xfrm>
+            <a:off x="11155680" y="6537960"/>
+            <a:ext cx="640080" cy="256032"/>
+          </a:xfrm>
+          <a:prstGeom prst="rect">
+            <a:avLst/>
+          </a:prstGeom>
+          <a:noFill/>
+        </p:spPr>
+        <p:txBody>
+          <a:bodyPr wrap="square">
+            <a:spAutoFit/>
+          </a:bodyPr>
+          <a:lstStyle/>
+          <a:p>
+            <a:pPr algn="r">
+              <a:spcAft>
+                <a:spcPts val="400"/>
+              </a:spcAft>
+            </a:pPr>
+            <a:r>
+              <a:rPr sz="1100" b="0">
+                <a:solidFill>
+                  <a:srgbClr val="5A5A5A"/>
+                </a:solidFill>
+                <a:latin typeface="Calibri"/>
+              </a:rPr>
+              <a:t>23</a:t>
+            </a:r>
+          </a:p>
+        </p:txBody>
+      </p:sp>
+      <p:sp>
+        <p:nvSpPr>
+          <p:cNvPr id="6" name="TextBox 5"/>
+          <p:cNvSpPr txBox="1"/>
+          <p:nvPr/>
+        </p:nvSpPr>
+        <p:spPr>
+          <a:xfrm>
+            <a:off x="411480" y="804672"/>
+            <a:ext cx="11338560" cy="411480"/>
+          </a:xfrm>
+          <a:prstGeom prst="rect">
+            <a:avLst/>
+          </a:prstGeom>
+          <a:noFill/>
+        </p:spPr>
+        <p:txBody>
+          <a:bodyPr wrap="square">
+            <a:spAutoFit/>
+          </a:bodyPr>
+          <a:lstStyle/>
+          <a:p>
+            <a:pPr algn="l">
+              <a:spcAft>
+                <a:spcPts val="400"/>
+              </a:spcAft>
+            </a:pPr>
+            <a:r>
+              <a:rPr sz="1500" b="0">
+                <a:solidFill>
+                  <a:srgbClr val="5A5A5A"/>
+                </a:solidFill>
+                <a:latin typeface="Calibri"/>
+              </a:rPr>
+              <a:t>EMD peels Intrinsic Mode Functions from the data. No Haar / D4 / LA8 bank is chosen in advance.</a:t>
+            </a:r>
+          </a:p>
+        </p:txBody>
+      </p:sp>
+      <p:sp>
+        <p:nvSpPr>
+          <p:cNvPr id="7" name="Rectangle 6"/>
+          <p:cNvSpPr/>
+          <p:nvPr/>
+        </p:nvSpPr>
+        <p:spPr>
+          <a:xfrm>
+            <a:off x="411480" y="1325880"/>
+            <a:ext cx="11338560" cy="1234440"/>
+          </a:xfrm>
+          <a:prstGeom prst="rect">
+            <a:avLst/>
+          </a:prstGeom>
+          <a:solidFill>
+            <a:srgbClr val="F7F9FB"/>
+          </a:solidFill>
+          <a:ln w="9525">
+            <a:solidFill>
+              <a:srgbClr val="C8D0D8"/>
+            </a:solidFill>
+          </a:ln>
+        </p:spPr>
+        <p:style>
+          <a:lnRef idx="1">
+            <a:schemeClr val="accent1"/>
+          </a:lnRef>
+          <a:fillRef idx="3">
+            <a:schemeClr val="accent1"/>
+          </a:fillRef>
+          <a:effectRef idx="2">
+            <a:schemeClr val="accent1"/>
+          </a:effectRef>
+          <a:fontRef idx="minor">
+            <a:schemeClr val="lt1"/>
+          </a:fontRef>
+        </p:style>
+        <p:txBody>
+          <a:bodyPr rtlCol="0" anchor="ctr"/>
+          <a:lstStyle/>
+          <a:p>
+            <a:pPr algn="ctr"/>
+          </a:p>
+        </p:txBody>
+      </p:sp>
+      <p:sp>
+        <p:nvSpPr>
+          <p:cNvPr id="8" name="TextBox 7"/>
+          <p:cNvSpPr txBox="1"/>
+          <p:nvPr/>
+        </p:nvSpPr>
+        <p:spPr>
+          <a:xfrm>
+            <a:off x="594360" y="1417320"/>
+            <a:ext cx="10972800" cy="1005840"/>
+          </a:xfrm>
+          <a:prstGeom prst="rect">
+            <a:avLst/>
+          </a:prstGeom>
+          <a:noFill/>
+        </p:spPr>
+        <p:txBody>
+          <a:bodyPr wrap="square">
+            <a:spAutoFit/>
+          </a:bodyPr>
+          <a:lstStyle/>
+          <a:p>
+            <a:pPr algn="l">
+              <a:spcAft>
+                <a:spcPts val="400"/>
+              </a:spcAft>
+            </a:pPr>
+            <a:r>
+              <a:rPr sz="1800" b="1">
+                <a:solidFill>
+                  <a:srgbClr val="1F3A5F"/>
+                </a:solidFill>
+                <a:latin typeface="Calibri"/>
+              </a:rPr>
+              <a:t>Y_t  =  IMF_1(t) + … + IMF_K(t) + r(t)</a:t>
+            </a:r>
+          </a:p>
+          <a:p>
+            <a:pPr algn="l">
+              <a:spcAft>
+                <a:spcPts val="400"/>
+              </a:spcAft>
+            </a:pPr>
+            <a:r>
+              <a:rPr sz="1500" b="0">
+                <a:solidFill>
+                  <a:srgbClr val="222222"/>
+                </a:solidFill>
+                <a:latin typeface="Calibri"/>
+              </a:rPr>
+              <a:t>We map IMF_1 → D_1, IMF_2 → D_2, … and put the residue in S_K, then use the same CatBoost / LightGBM head as WaveCatBoost.</a:t>
+            </a:r>
+          </a:p>
+        </p:txBody>
+      </p:sp>
+      <p:sp>
+        <p:nvSpPr>
+          <p:cNvPr id="9" name="Rectangle 8"/>
+          <p:cNvSpPr/>
+          <p:nvPr/>
+        </p:nvSpPr>
+        <p:spPr>
+          <a:xfrm>
+            <a:off x="411480" y="2743200"/>
+            <a:ext cx="5532120" cy="3383280"/>
+          </a:xfrm>
+          <a:prstGeom prst="rect">
+            <a:avLst/>
+          </a:prstGeom>
+          <a:solidFill>
+            <a:srgbClr val="F7F9FB"/>
+          </a:solidFill>
+          <a:ln w="9525">
+            <a:solidFill>
+              <a:srgbClr val="C8D0D8"/>
+            </a:solidFill>
+          </a:ln>
+        </p:spPr>
+        <p:style>
+          <a:lnRef idx="1">
+            <a:schemeClr val="accent1"/>
+          </a:lnRef>
+          <a:fillRef idx="3">
+            <a:schemeClr val="accent1"/>
+          </a:fillRef>
+          <a:effectRef idx="2">
+            <a:schemeClr val="accent1"/>
+          </a:effectRef>
+          <a:fontRef idx="minor">
+            <a:schemeClr val="lt1"/>
+          </a:fontRef>
+        </p:style>
+        <p:txBody>
+          <a:bodyPr rtlCol="0" anchor="ctr"/>
+          <a:lstStyle/>
+          <a:p>
+            <a:pPr algn="ctr"/>
+          </a:p>
+        </p:txBody>
+      </p:sp>
+      <p:sp>
+        <p:nvSpPr>
+          <p:cNvPr id="10" name="Rectangle 9"/>
+          <p:cNvSpPr/>
+          <p:nvPr/>
+        </p:nvSpPr>
+        <p:spPr>
+          <a:xfrm>
+            <a:off x="6217920" y="2743200"/>
+            <a:ext cx="5532120" cy="3383280"/>
+          </a:xfrm>
+          <a:prstGeom prst="rect">
+            <a:avLst/>
+          </a:prstGeom>
+          <a:solidFill>
+            <a:srgbClr val="F7F9FB"/>
+          </a:solidFill>
+          <a:ln w="9525">
+            <a:solidFill>
+              <a:srgbClr val="C8D0D8"/>
+            </a:solidFill>
+          </a:ln>
+        </p:spPr>
+        <p:style>
+          <a:lnRef idx="1">
+            <a:schemeClr val="accent1"/>
+          </a:lnRef>
+          <a:fillRef idx="3">
+            <a:schemeClr val="accent1"/>
+          </a:fillRef>
+          <a:effectRef idx="2">
+            <a:schemeClr val="accent1"/>
+          </a:effectRef>
+          <a:fontRef idx="minor">
+            <a:schemeClr val="lt1"/>
+          </a:fontRef>
+        </p:style>
+        <p:txBody>
+          <a:bodyPr rtlCol="0" anchor="ctr"/>
+          <a:lstStyle/>
+          <a:p>
+            <a:pPr algn="ctr"/>
+          </a:p>
+        </p:txBody>
+      </p:sp>
+      <p:sp>
+        <p:nvSpPr>
+          <p:cNvPr id="11" name="TextBox 10"/>
+          <p:cNvSpPr txBox="1"/>
+          <p:nvPr/>
+        </p:nvSpPr>
+        <p:spPr>
+          <a:xfrm>
+            <a:off x="594360" y="2880360"/>
+            <a:ext cx="5212080" cy="3108960"/>
+          </a:xfrm>
+          <a:prstGeom prst="rect">
+            <a:avLst/>
+          </a:prstGeom>
+          <a:noFill/>
+        </p:spPr>
+        <p:txBody>
+          <a:bodyPr wrap="square">
+            <a:spAutoFit/>
+          </a:bodyPr>
+          <a:lstStyle/>
+          <a:p>
+            <a:pPr algn="l">
+              <a:spcAft>
+                <a:spcPts val="400"/>
+              </a:spcAft>
+            </a:pPr>
+            <a:r>
+              <a:rPr sz="1600" b="1">
+                <a:solidFill>
+                  <a:srgbClr val="1F3A5F"/>
+                </a:solidFill>
+                <a:latin typeface="Calibri"/>
+              </a:rPr>
+              <a:t>What EMD gives</a:t>
+            </a:r>
+          </a:p>
+          <a:p>
+            <a:pPr algn="l">
+              <a:spcAft>
+                <a:spcPts val="400"/>
+              </a:spcAft>
+            </a:pPr>
+            <a:r>
+              <a:rPr sz="1500" b="0">
+                <a:solidFill>
+                  <a:srgbClr val="222222"/>
+                </a:solidFill>
+                <a:latin typeface="Calibri"/>
+              </a:rPr>
+              <a:t>Bands adapt to the series, so a rare dust event need not sit in a fixed 2–4 h octave.</a:t>
+            </a:r>
+          </a:p>
+          <a:p>
+            <a:pPr algn="l">
+              <a:spcAft>
+                <a:spcPts val="400"/>
+              </a:spcAft>
+            </a:pPr>
+            <a:r>
+              <a:rPr sz="1500" b="0">
+                <a:solidFill>
+                  <a:srgbClr val="222222"/>
+                </a:solidFill>
+                <a:latin typeface="Calibri"/>
+              </a:rPr>
+              <a:t>Reconstruction is exact: IMFs plus residue return Y_t.</a:t>
+            </a:r>
+          </a:p>
+          <a:p>
+            <a:pPr algn="l">
+              <a:spcAft>
+                <a:spcPts val="400"/>
+              </a:spcAft>
+            </a:pPr>
+            <a:r>
+              <a:rPr sz="1500" b="0">
+                <a:solidFill>
+                  <a:srgbClr val="222222"/>
+                </a:solidFill>
+                <a:latin typeface="Calibri"/>
+              </a:rPr>
+              <a:t>Shown on the first 500 hours in analysis.Rmd §10.3.</a:t>
+            </a:r>
+          </a:p>
+        </p:txBody>
+      </p:sp>
+      <p:sp>
+        <p:nvSpPr>
+          <p:cNvPr id="12" name="TextBox 11"/>
+          <p:cNvSpPr txBox="1"/>
+          <p:nvPr/>
+        </p:nvSpPr>
+        <p:spPr>
+          <a:xfrm>
+            <a:off x="6400800" y="2880360"/>
+            <a:ext cx="5212080" cy="3108960"/>
+          </a:xfrm>
+          <a:prstGeom prst="rect">
+            <a:avLst/>
+          </a:prstGeom>
+          <a:noFill/>
+        </p:spPr>
+        <p:txBody>
+          <a:bodyPr wrap="square">
+            <a:spAutoFit/>
+          </a:bodyPr>
+          <a:lstStyle/>
+          <a:p>
+            <a:pPr algn="l">
+              <a:spcAft>
+                <a:spcPts val="400"/>
+              </a:spcAft>
+            </a:pPr>
+            <a:r>
+              <a:rPr sz="1600" b="1">
+                <a:solidFill>
+                  <a:srgbClr val="A64B2A"/>
+                </a:solidFill>
+                <a:latin typeface="Calibri"/>
+              </a:rPr>
+              <a:t>Why Haar still wins as the default</a:t>
+            </a:r>
+          </a:p>
+          <a:p>
+            <a:pPr algn="l">
+              <a:spcAft>
+                <a:spcPts val="400"/>
+              </a:spcAft>
+            </a:pPr>
+            <a:r>
+              <a:rPr sz="1500" b="0">
+                <a:solidFill>
+                  <a:srgbClr val="222222"/>
+                </a:solidFill>
+                <a:latin typeface="Calibri"/>
+              </a:rPr>
+              <a:t>Mode mixing: two different events with a similar local period can land in one IMF.</a:t>
+            </a:r>
+          </a:p>
+          <a:p>
+            <a:pPr algn="l">
+              <a:spcAft>
+                <a:spcPts val="400"/>
+              </a:spcAft>
+            </a:pPr>
+            <a:r>
+              <a:rPr sz="1500" b="0">
+                <a:solidFill>
+                  <a:srgbClr val="222222"/>
+                </a:solidFill>
+                <a:latin typeface="Calibri"/>
+              </a:rPr>
+              <a:t>Cost is much higher than O(N K) Haar.</a:t>
+            </a:r>
+          </a:p>
+          <a:p>
+            <a:pPr algn="l">
+              <a:spcAft>
+                <a:spcPts val="400"/>
+              </a:spcAft>
+            </a:pPr>
+            <a:r>
+              <a:rPr sz="1500" b="0">
+                <a:solidFill>
+                  <a:srgbClr val="222222"/>
+                </a:solidFill>
+                <a:latin typeface="Calibri"/>
+              </a:rPr>
+              <a:t>Haar D_1 is always the 2–4 h band, so lag features mean the same thing every day.</a:t>
+            </a:r>
+          </a:p>
+        </p:txBody>
+      </p:sp>
+    </p:spTree>
+  </p:cSld>
+  <p:clrMapOvr>
+    <a:masterClrMapping/>
+  </p:clrMapOvr>
+</p:sld>
+</file>
+
+<file path=ppt/slides/slide24.xml><?xml version="1.0" encoding="utf-8"?>
 <p:sld xmlns:a="http://schemas.openxmlformats.org/drawingml/2006/main" xmlns:r="http://schemas.openxmlformats.org/officeDocument/2006/relationships" xmlns:p="http://schemas.openxmlformats.org/presentationml/2006/main">
   <p:cSld>
     <p:spTree>
@@ -16230,7 +18522,7 @@
                 </a:solidFill>
                 <a:latin typeface="Calibri"/>
               </a:rPr>
-              <a:t>20</a:t>
+              <a:t>24</a:t>
             </a:r>
           </a:p>
         </p:txBody>

</xml_diff>